<commit_message>
Corregir datos del negocio en la presentación de Buenas Migas
Elimina la mención a dos sedes (solo existe una, Carrera 7 # 72A-80) y
al dato no verificado de 24 años de trayectoria; reemplaza "cajas
sorpresa" por "cajas de regalo" en todas las diapositivas y notas.

Co-Authored-By: Claude Sonnet 5 <noreply@anthropic.com>
Claude-Session: https://claude.ai/code/session_01SmkHKcxHsRiRKSPUZSC2qb
</commit_message>
<xml_diff>
--- a/Panadería Buenas Migas - Estrategia Meta Ads/Buenas_Migas_Meta_Ads.pptx
+++ b/Panadería Buenas Migas - Estrategia Meta Ads/Buenas_Migas_Meta_Ads.pptx
@@ -1151,8 +1151,8 @@
             <a:r>
               <a:rPr lang="en-US" dirty="0"/>
               <a:t>OBJETIVO: Mostrar un plan de trabajo concreto para los primeros 3 meses, conectando cada mes con un producto protagonista.
-MENSAJE PRINCIPAL: La metodología de las 4 etapas se activa de forma progresiva mes a mes, empezando por las cajas sorpresa, siguiendo con pedidos institucionales, y cerrando con cajas premium.
-QUÉ EXPLICAR: Mes 1 da a conocer las cajas sorpresa apoyado en video del proceso artesanal. Mes 2 construye confianza con reseñas y respaldo institucional, y abre las primeras conversiones por WhatsApp. Mes 3 escala lo que mejor funciona y presenta las cajas premium, arrancando ya la etapa de ascensión.</a:t>
+MENSAJE PRINCIPAL: La metodología de las 4 etapas se activa de forma progresiva mes a mes, empezando por las cajas de regalo, siguiendo con pedidos institucionales, y cerrando con cajas premium.
+QUÉ EXPLICAR: Mes 1 da a conocer las cajas de regalo apoyado en video del proceso artesanal. Mes 2 construye confianza con reseñas y respaldo institucional, y abre las primeras conversiones por WhatsApp. Mes 3 escala lo que mejor funciona y presenta las cajas premium, arrancando ya la etapa de ascensión.</a:t>
             </a:r>
             <a:endParaRPr lang="en-US" dirty="0"/>
           </a:p>
@@ -1242,7 +1242,7 @@
               <a:rPr lang="en-US" dirty="0"/>
               <a:t>OBJETIVO: Dar seguridad mostrando un cronograma detallado y realista para los primeros 3 meses.
 MENSAJE PRINCIPAL: Cada quincena tiene un entregable concreto; no hay ambigüedad sobre qué se está haciendo en cada momento.
-QUÉ EXPLICAR: Las dos primeras semanas son de base técnica (auditoría de la cuenta y de los 6 anuncios activos), no de campañas nuevas todavía. A partir de la semana 3 empieza la etapa de Presentación con las cajas sorpresa, y el sistema se va completando progresivamente hasta arrancar Ascensión al final del mes 3.</a:t>
+QUÉ EXPLICAR: Las dos primeras semanas son de base técnica (auditoría de la cuenta y de los 6 anuncios activos), no de campañas nuevas todavía. A partir de la semana 3 empieza la etapa de Presentación con las cajas de regalo, y el sistema se va completando progresivamente hasta arrancar Ascensión al final del mes 3.</a:t>
             </a:r>
             <a:endParaRPr lang="en-US" dirty="0"/>
           </a:p>
@@ -1511,8 +1511,8 @@
             <a:r>
               <a:rPr lang="en-US" dirty="0"/>
               <a:t>OBJETIVO: Establecer el punto de partida real, reconociendo lo que ya existe antes de hablar de lo que falta.
-MENSAJE PRINCIPAL: Buenas Migas ya tiene 24 años de trayectoria, dos sedes activas y una marca reconocida en Bogotá; lo que no tiene es un sistema de Meta Ads detrás de los 6 anuncios que corren hoy.
-QUÉ EXPLICAR: Los 6 anuncios activos están mal estructurados y sin optimizar, ambas sedes comparten los mismos anuncios genéricos y no existe ninguna etapa de decisión del cliente cubierta.</a:t>
+MENSAJE PRINCIPAL: Buenas Migas ya tiene una marca reconocida en Bogotá y una audiencia real en redes (53.900 seguidores en Instagram); lo que no tiene es un sistema de Meta Ads detrás de los 6 anuncios que corren hoy.
+QUÉ EXPLICAR: Los 6 anuncios activos están mal estructurados y sin optimizar, la audiencia en redes no tiene ningún sistema de remarketing detrás, y no existe ninguna etapa de decisión del cliente cubierta.</a:t>
             </a:r>
             <a:endParaRPr lang="en-US" dirty="0"/>
           </a:p>
@@ -1781,8 +1781,8 @@
             <a:r>
               <a:rPr lang="en-US" dirty="0"/>
               <a:t>OBJETIVO DE LA ETAPA: Lograr que nuevas personas en Bogotá descubran Buenas Migas. Aquí no se vende, se despierta interés.
-MENSAJE PRINCIPAL: En esta etapa no medimos pedidos; medimos alcance calificado en Chapinero, Chicó y el resto de Bogotá.
-QUÉ EXPLICAR: Formatos de video mostrando el proceso artesanal; las cajas sorpresa como producto ancla; y que el éxito se mide en alcance, no en ventas inmediatas.</a:t>
+MENSAJE PRINCIPAL: En esta etapa no medimos pedidos; medimos alcance calificado en Chapinero y el resto de Bogotá.
+QUÉ EXPLICAR: Formatos de video mostrando el proceso artesanal; las cajas de regalo como producto ancla; y que el éxito se mide en alcance, no en ventas inmediatas.</a:t>
             </a:r>
             <a:endParaRPr lang="en-US" dirty="0"/>
           </a:p>
@@ -1872,7 +1872,7 @@
               <a:rPr lang="en-US" dirty="0"/>
               <a:t>OBJETIVO: Dar profundidad al contenido creativo de la etapa 1.
 MENSAJE PRINCIPAL: No se trata de un anuncio genérico de panadería, sino de piezas que cubren distintos ángulos de decisión.
-QUÉ EXPLICAR: Recorrer cada pilar. Las cajas y desayunos sorpresa son el producto más regalable y deben ser el ancla de descubrimiento; los 24 años de tradición artesanal dan autoridad; los pedidos institucionales abren la puerta a empresas.</a:t>
+QUÉ EXPLICAR: Recorrer cada pilar. Las cajas y desayunos de regalo son el producto más regalable y deben ser el ancla de descubrimiento; el carácter 100% artesanal da autoridad; los pedidos institucionales abren la puerta a empresas.</a:t>
             </a:r>
             <a:endParaRPr lang="en-US" dirty="0"/>
           </a:p>
@@ -2140,9 +2140,9 @@
           <a:p>
             <a:r>
               <a:rPr lang="en-US" dirty="0"/>
-              <a:t>OBJETIVO DE LA ETAPA: Convertir el interés calificado en pedidos reales de cajas, desayunos sorpresa o eventos institucionales.
+              <a:t>OBJETIVO DE LA ETAPA: Convertir el interés calificado en pedidos reales de cajas, desayunos de regalo o eventos institucionales.
 MENSAJE PRINCIPAL: En conversión no buscamos alcance, buscamos precisión: solo se invierte en quien ya mostró interés real.
-QUÉ EXPLICAR: Las audiencias se restringen a quienes vieron videos o interactuaron con los anuncios de confianza. El CTA es directo: pedir por WhatsApp, recoger o pedir entrega en Chapinero o Chicó.</a:t>
+QUÉ EXPLICAR: Las audiencias se restringen a quienes vieron videos o interactuaron con los anuncios de confianza. El CTA es directo: pedir por WhatsApp, recoger o pedir entrega en el punto de venta.</a:t>
             </a:r>
             <a:endParaRPr lang="en-US" dirty="0"/>
           </a:p>
@@ -7447,7 +7447,7 @@
                 <a:ea typeface="Calibri" pitchFamily="34" charset="-122"/>
                 <a:cs typeface="Calibri" pitchFamily="34" charset="-120"/>
               </a:rPr>
-              <a:t>Diseñar públicos personalizados por sede: Chapinero y Chicó.</a:t>
+              <a:t>Diseñar un público personalizado por cercanía al punto de venta en la Carrera 7.</a:t>
             </a:r>
             <a:endParaRPr lang="en-US" sz="1020" dirty="0"/>
           </a:p>
@@ -7983,7 +7983,7 @@
                 <a:ea typeface="Calibri" pitchFamily="34" charset="-122"/>
                 <a:cs typeface="Calibri" pitchFamily="34" charset="-120"/>
               </a:rPr>
-              <a:t>Cajas y desayunos sorpresa</a:t>
+              <a:t>Cajas y desayunos de regalo</a:t>
             </a:r>
             <a:endParaRPr lang="en-US" sz="1050" dirty="0"/>
           </a:p>
@@ -8086,7 +8086,7 @@
                 <a:ea typeface="Calibri" pitchFamily="34" charset="-122"/>
                 <a:cs typeface="Calibri" pitchFamily="34" charset="-120"/>
               </a:rPr>
-              <a:t>Campañas de reconocimiento dirigidas a Chapinero, Chicó y Bogotá</a:t>
+              <a:t>Campañas de reconocimiento dirigidas a Bogotá</a:t>
             </a:r>
             <a:endParaRPr lang="en-US" sz="1030" dirty="0"/>
           </a:p>
@@ -9293,7 +9293,7 @@
                 <a:ea typeface="Calibri" pitchFamily="34" charset="-122"/>
                 <a:cs typeface="Calibri" pitchFamily="34" charset="-120"/>
               </a:rPr>
-              <a:t>Lanzamiento de campañas de Presentación — cajas y desayuno sorpresa</a:t>
+              <a:t>Lanzamiento de campañas de Presentación — cajas y desayunos de regalo</a:t>
             </a:r>
             <a:endParaRPr lang="en-US" sz="1000" dirty="0"/>
           </a:p>
@@ -11497,7 +11497,7 @@
                 <a:ea typeface="Cambria" pitchFamily="34" charset="-122"/>
                 <a:cs typeface="Cambria" pitchFamily="34" charset="-120"/>
               </a:rPr>
-              <a:t>2 sedes</a:t>
+              <a:t>53.900</a:t>
             </a:r>
             <a:endParaRPr lang="en-US" sz="2200" dirty="0"/>
           </a:p>
@@ -11536,7 +11536,7 @@
                 <a:ea typeface="Calibri" pitchFamily="34" charset="-122"/>
                 <a:cs typeface="Calibri" pitchFamily="34" charset="-120"/>
               </a:rPr>
-              <a:t>Chapinero y Chicó, hoy promocionadas con los mismos anuncios genéricos</a:t>
+              <a:t>Seguidores en Instagram, sin ningún sistema de remarketing detrás</a:t>
             </a:r>
             <a:endParaRPr lang="en-US" sz="1150" dirty="0"/>
           </a:p>
@@ -11724,7 +11724,7 @@
                 <a:ea typeface="Calibri" pitchFamily="34" charset="-122"/>
                 <a:cs typeface="Calibri" pitchFamily="34" charset="-120"/>
               </a:rPr>
-              <a:t>24 años de trayectoria, dos sedes activas y una marca reconocida en Bogotá ya existen. Falta el sistema que convierta cada peso invertido en un cliente que descubre, confía, compra y vuelve.</a:t>
+              <a:t>Una marca ya reconocida en Bogotá, con una audiencia real en redes, ya existe. Falta el sistema que convierta cada peso invertido en un cliente que descubre, confía, compra y vuelve.</a:t>
             </a:r>
             <a:endParaRPr lang="en-US" sz="1300" dirty="0"/>
           </a:p>
@@ -13759,7 +13759,7 @@
                 <a:ea typeface="Calibri" pitchFamily="34" charset="-122"/>
                 <a:cs typeface="Calibri" pitchFamily="34" charset="-120"/>
               </a:rPr>
-              <a:t>Chapinero, Chicó y Bogotá</a:t>
+              <a:t>Chapinero y Bogotá</a:t>
             </a:r>
             <a:endParaRPr lang="en-US" sz="1300" dirty="0"/>
           </a:p>
@@ -13842,7 +13842,7 @@
                 <a:ea typeface="Calibri" pitchFamily="34" charset="-122"/>
                 <a:cs typeface="Calibri" pitchFamily="34" charset="-120"/>
               </a:rPr>
-              <a:t>Cajas sorpresa</a:t>
+              <a:t>Cajas de regalo</a:t>
             </a:r>
             <a:endParaRPr lang="en-US" sz="1300" dirty="0"/>
           </a:p>
@@ -14042,7 +14042,7 @@
                 <a:ea typeface="Calibri" pitchFamily="34" charset="-122"/>
                 <a:cs typeface="Calibri" pitchFamily="34" charset="-120"/>
               </a:rPr>
-              <a:t>24 años de</a:t>
+              <a:t>Pan</a:t>
             </a:r>
             <a:endParaRPr lang="en-US" sz="1300" dirty="0"/>
           </a:p>
@@ -14059,7 +14059,7 @@
                 <a:ea typeface="Calibri" pitchFamily="34" charset="-122"/>
                 <a:cs typeface="Calibri" pitchFamily="34" charset="-120"/>
               </a:rPr>
-              <a:t>tradición</a:t>
+              <a:t>100% artesanal</a:t>
             </a:r>
             <a:endParaRPr lang="en-US" sz="1300" dirty="0"/>
           </a:p>
@@ -14345,7 +14345,7 @@
                 <a:ea typeface="Cambria" pitchFamily="34" charset="-122"/>
                 <a:cs typeface="Cambria" pitchFamily="34" charset="-120"/>
               </a:rPr>
-              <a:t>Cajas y desayunos sorpresa</a:t>
+              <a:t>Cajas y desayunos de regalo</a:t>
             </a:r>
             <a:endParaRPr lang="en-US" sz="1450" dirty="0"/>
           </a:p>
@@ -14528,7 +14528,7 @@
                 <a:ea typeface="Calibri" pitchFamily="34" charset="-122"/>
                 <a:cs typeface="Calibri" pitchFamily="34" charset="-120"/>
               </a:rPr>
-              <a:t>24 años de tradición horneando con las recetas del fundador</a:t>
+              <a:t>Una promesa de calidad artesanal que distingue a la marca</a:t>
             </a:r>
             <a:endParaRPr lang="en-US" sz="1150" dirty="0"/>
           </a:p>
@@ -16853,7 +16853,7 @@
                 <a:ea typeface="Calibri" pitchFamily="34" charset="-122"/>
                 <a:cs typeface="Calibri" pitchFamily="34" charset="-120"/>
               </a:rPr>
-              <a:t>en Chapinero y Chicó</a:t>
+              <a:t>en el punto de venta</a:t>
             </a:r>
             <a:endParaRPr lang="en-US" sz="1300" dirty="0"/>
           </a:p>

</xml_diff>